<commit_message>
fix(slides): KOEA-8258 — fix truncated bullets and add missing 3rd bullet in ch02-slides.pptx
- Slides 3-6: replaced 9 bullets truncated mid-word (125-char cap artifact)
  with complete concise versions (≤15 words each)
- Slide 4: added 3rd content bullet (was 2; minimum is 3 per G0 checklist)
- All bullets verified via python-pptx: no mid-word truncations remain

Co-Authored-By: Claude Sonnet 4.6 <noreply@anthropic.com>
</commit_message>
<xml_diff>
--- a/vault/courses/microsoft-advertising-bing-ads/ch02-slides.pptx
+++ b/vault/courses/microsoft-advertising-bing-ads/ch02-slides.pptx
@@ -3609,7 +3609,7 @@
                   <a:srgbClr val="FFFFFF"/>
                 </a:solidFill>
               </a:rPr>
-              <a:t>  •  The New Import Center (launched May 2026) consolidates all Google Ads and Meta imports into a single searchable, filtera</a:t>
+              <a:t>  •  New Import Center (May 2026) unifies Google Ads and Meta imports in one filterable dashboard with inline error resolution</a:t>
             </a:r>
           </a:p>
         </p:txBody>
@@ -3643,7 +3643,7 @@
                   <a:srgbClr val="FFFFFF"/>
                 </a:solidFill>
               </a:rPr>
-              <a:t>  •  To create it: type "Import credential ID" in the Microsoft Advertising platform search bar, authenticate with the Google</a:t>
+              <a:t>  •  Type "Import credential ID" in the platform search bar, authenticate with Google, and copy the resulting credential ID</a:t>
             </a:r>
           </a:p>
         </p:txBody>
@@ -3677,7 +3677,7 @@
                   <a:srgbClr val="FFFFFF"/>
                 </a:solidFill>
               </a:rPr>
-              <a:t>  •  With the credential ready, navigate to Tools → Import → Import from Google Ads or open the Import Center directly. Sign </a:t>
+              <a:t>  •  With the credential ready, go to Tools → Import → Import from Google Ads; sign in with Google to select the source account</a:t>
             </a:r>
           </a:p>
         </p:txBody>
@@ -3848,7 +3848,7 @@
                   <a:srgbClr val="FFFFFF"/>
                 </a:solidFill>
               </a:rPr>
-              <a:t>  •  Name your import job clearly — for example, "Weekly Sync — US Search." Under Schedule, choose a frequency: Auto (Microso</a:t>
+              <a:t>  •  Name the import job and pick a cadence — Auto delegates the optimal sync frequency to Microsoft Advertising</a:t>
             </a:r>
           </a:p>
         </p:txBody>
@@ -3882,7 +3882,7 @@
                   <a:srgbClr val="FFFFFF"/>
                 </a:solidFill>
               </a:rPr>
-              <a:t>  •  Before clicking Import, select Advanced import options — not the plain "Start import" button. The default path lets Micr</a:t>
+              <a:t>  •  Always use Advanced import options — the default Start Import path silently applies Microsoft's own preferences to every flag</a:t>
             </a:r>
           </a:p>
         </p:txBody>
@@ -3917,6 +3917,40 @@
                 </a:solidFill>
               </a:rPr>
               <a:t>academy.kspl.tech | Koenig AI Academy</a:t>
+            </a:r>
+          </a:p>
+        </p:txBody>
+      </p:sp>
+      <p:sp>
+        <p:nvSpPr>
+          <p:cNvPr id="5" name="TextBox 3b"/>
+          <p:cNvSpPr txBox="1"/>
+          <p:nvPr/>
+        </p:nvSpPr>
+        <p:spPr>
+          <a:xfrm>
+            <a:off x="731520" y="3794760"/>
+            <a:ext cx="10698480" cy="1005840"/>
+          </a:xfrm>
+          <a:prstGeom prst="rect">
+            <a:avLst/>
+          </a:prstGeom>
+          <a:noFill/>
+        </p:spPr>
+        <p:txBody>
+          <a:bodyPr wrap="square">
+            <a:spAutoFit/>
+          </a:bodyPr>
+          <a:lstStyle/>
+          <a:p>
+            <a:pPr algn="l"/>
+            <a:r>
+              <a:rPr sz="1600" b="0">
+                <a:solidFill>
+                  <a:srgbClr val="FFFFFF"/>
+                </a:solidFill>
+              </a:rPr>
+              <a:t>  •  After import completes, verify the job in Import Center shows the Next run time and schedule</a:t>
             </a:r>
           </a:p>
         </p:txBody>
@@ -4087,7 +4121,7 @@
                   <a:srgbClr val="FFFFFF"/>
                 </a:solidFill>
               </a:rPr>
-              <a:t>  •  For any first import, set PauseNewCampaigns = Yes. The GoogleImportOption reference documents every flag in full. Treati</a:t>
+              <a:t>  •  Set PauseNewCampaigns = Yes on every first import; treating the defaults as safe is the leading cause of day-one overspend</a:t>
             </a:r>
           </a:p>
         </p:txBody>
@@ -4121,7 +4155,7 @@
                   <a:srgbClr val="FFFFFF"/>
                 </a:solidFill>
               </a:rPr>
-              <a:t>  •  PauseNewCampaigns defaults to false. On a first import, all new campaigns launch immediately and begin spending before a</a:t>
+              <a:t>  •  PauseNewCampaigns defaults to false — new campaigns launch immediately and spend before any audit is complete</a:t>
             </a:r>
           </a:p>
         </p:txBody>
@@ -4292,7 +4326,7 @@
                   <a:srgbClr val="FFFFFF"/>
                 </a:solidFill>
               </a:rPr>
-              <a:t>  •  After the import runs, open the Import Center, click the import name, and review the Added / Updated / Skipped / Errors </a:t>
+              <a:t>  •  Open Import Center after each run and review the Added, Updated, Skipped, and Errors tallies for the import job</a:t>
             </a:r>
           </a:p>
         </p:txBody>
@@ -4394,7 +4428,7 @@
                   <a:srgbClr val="FFFFFF"/>
                 </a:solidFill>
               </a:rPr>
-              <a:t>  •  Bid strategies — Any campaign using Google Smart Bidding now shows "Enhanced CPC." This is a silent conversion with no e</a:t>
+              <a:t>  •  Bid strategies: Smart Bidding campaigns silently convert to Enhanced CPC — no error is logged; manually reassign after import</a:t>
             </a:r>
           </a:p>
         </p:txBody>

</xml_diff>